<commit_message>
Both strips on one A4 sheet
The deck was two slides at sign size, which meant two sheets through the
printer. Now one A4 landscape slide carrying both strips with a dashed cut
line between them: one sheet, one cut, one of each language.

Checked by reading the deck back rather than by eye - LibreOffice cannot
run on this machine - and every run measured against its box with the real
Windows font files. 18 shapes, nothing off-page, nothing overflowing.

Co-Authored-By: Claude Opus 5 <noreply@anthropic.com>
</commit_message>
<xml_diff>
--- a/print/banner.pptx
+++ b/print/banner.pptx
@@ -6,9 +6,8 @@
   </p:sldMasterIdLst>
   <p:sldIdLst>
     <p:sldId id="256" r:id="rId7"/>
-    <p:sldId id="257" r:id="rId9"/>
   </p:sldIdLst>
-  <p:sldSz cx="10116000" cy="3312000" type="screen4x3"/>
+  <p:sldSz cx="10692000" cy="7560000" type="screen4x3"/>
   <p:notesSz cx="6858000" cy="9144000"/>
   <p:defaultTextStyle>
     <a:defPPr>
@@ -503,89 +502,7 @@
           <a:lstStyle/>
           <a:p>
             <a:r>
-              <a:t>Finished size 281 x 92 mm. Print at 100% scale with background graphics switched on, or the maroon bar will not appear.</a:t>
-            </a:r>
-          </a:p>
-          <a:p/>
-          <a:p>
-            <a:r>
-              <a:t>The QR code points at oberrieden.pub/review, which redirects to the pub's Google listing. If that Google link ever changes, the redirect is what changes - this code stays valid, so printed copies keep working.</a:t>
-            </a:r>
-          </a:p>
-          <a:p/>
-          <a:p>
-            <a:r>
-              <a:t>Do not put this up until the website is live and approved.</a:t>
-            </a:r>
-          </a:p>
-        </p:txBody>
-      </p:sp>
-      <p:sp>
-        <p:nvSpPr>
-          <p:cNvPr id="4" name="Slide Number Placeholder 3"/>
-          <p:cNvSpPr>
-            <a:spLocks noGrp="1"/>
-          </p:cNvSpPr>
-          <p:nvPr>
-            <p:ph type="sldNum" idx="5" sz="quarter"/>
-          </p:nvPr>
-        </p:nvSpPr>
-        <p:spPr/>
-      </p:sp>
-    </p:spTree>
-  </p:cSld>
-  <p:clrMapOvr>
-    <a:masterClrMapping/>
-  </p:clrMapOvr>
-</p:notes>
-</file>
-
-<file path=ppt/notesSlides/notesSlide2.xml><?xml version="1.0" encoding="utf-8"?>
-<p:notes xmlns:a="http://schemas.openxmlformats.org/drawingml/2006/main" xmlns:p="http://schemas.openxmlformats.org/presentationml/2006/main" xmlns:r="http://schemas.openxmlformats.org/officeDocument/2006/relationships">
-  <p:cSld>
-    <p:spTree>
-      <p:nvGrpSpPr>
-        <p:cNvPr id="1" name=""/>
-        <p:cNvGrpSpPr/>
-        <p:nvPr/>
-      </p:nvGrpSpPr>
-      <p:grpSpPr>
-        <a:xfrm>
-          <a:off x="0" y="0"/>
-          <a:ext cx="0" cy="0"/>
-          <a:chOff x="0" y="0"/>
-          <a:chExt cx="0" cy="0"/>
-        </a:xfrm>
-      </p:grpSpPr>
-      <p:sp>
-        <p:nvSpPr>
-          <p:cNvPr id="2" name="Slide Image Placeholder 1"/>
-          <p:cNvSpPr>
-            <a:spLocks noGrp="1"/>
-          </p:cNvSpPr>
-          <p:nvPr>
-            <p:ph type="sldImg" idx="2"/>
-          </p:nvPr>
-        </p:nvSpPr>
-        <p:spPr/>
-      </p:sp>
-      <p:sp>
-        <p:nvSpPr>
-          <p:cNvPr id="3" name="Notes Placeholder 2"/>
-          <p:cNvSpPr>
-            <a:spLocks noGrp="1"/>
-          </p:cNvSpPr>
-          <p:nvPr>
-            <p:ph type="body" idx="3" sz="quarter"/>
-          </p:nvPr>
-        </p:nvSpPr>
-        <p:spPr/>
-        <p:txBody>
-          <a:bodyPr/>
-          <a:lstStyle/>
-          <a:p>
-            <a:r>
-              <a:t>Finished size 281 x 92 mm. Print at 100% scale with background graphics switched on, or the maroon bar will not appear.</a:t>
+              <a:t>One A4 landscape sheet, two strips, one cut. Finished size 281 x 92 mm each. Print at 100% scale with background graphics switched on, or the maroon bar will not appear.</a:t>
             </a:r>
           </a:p>
           <a:p/>
@@ -3599,7 +3516,7 @@
     <p:bg>
       <p:bgPr>
         <a:solidFill>
-          <a:srgbClr val="FBF7F0"/>
+          <a:srgbClr val="FFFFFF"/>
         </a:solidFill>
         <a:effectLst/>
       </p:bgPr>
@@ -3619,8 +3536,8 @@
         </p:nvSpPr>
         <p:spPr>
           <a:xfrm>
-            <a:off x="18000" y="18000"/>
-            <a:ext cx="10080000" cy="3276000"/>
+            <a:off x="288000" y="288000"/>
+            <a:ext cx="10116000" cy="3312000"/>
           </a:xfrm>
           <a:prstGeom prst="rect">
             <a:avLst/>
@@ -3663,7 +3580,7 @@
         </p:nvSpPr>
         <p:spPr>
           <a:xfrm>
-            <a:off x="0" y="0"/>
+            <a:off x="288000" y="288000"/>
             <a:ext cx="10116000" cy="432000"/>
           </a:xfrm>
           <a:prstGeom prst="rect">
@@ -3705,7 +3622,7 @@
         </p:nvSpPr>
         <p:spPr>
           <a:xfrm>
-            <a:off x="504000" y="0"/>
+            <a:off x="792000" y="288000"/>
             <a:ext cx="9108000" cy="432000"/>
           </a:xfrm>
           <a:prstGeom prst="rect">
@@ -3740,7 +3657,7 @@
         </p:nvSpPr>
         <p:spPr>
           <a:xfrm>
-            <a:off x="504000" y="1188000"/>
+            <a:off x="792000" y="1476000"/>
             <a:ext cx="7092000" cy="720000"/>
           </a:xfrm>
           <a:prstGeom prst="rect">
@@ -3775,7 +3692,7 @@
         </p:nvSpPr>
         <p:spPr>
           <a:xfrm>
-            <a:off x="504000" y="1962000"/>
+            <a:off x="792000" y="2250000"/>
             <a:ext cx="7092000" cy="288000"/>
           </a:xfrm>
           <a:prstGeom prst="rect">
@@ -3810,7 +3727,7 @@
         </p:nvSpPr>
         <p:spPr>
           <a:xfrm>
-            <a:off x="504000" y="2304000"/>
+            <a:off x="792000" y="2592000"/>
             <a:ext cx="7092000" cy="252000"/>
           </a:xfrm>
           <a:prstGeom prst="rect">
@@ -3853,7 +3770,7 @@
         </p:blipFill>
         <p:spPr>
           <a:xfrm>
-            <a:off x="7812000" y="846000"/>
+            <a:off x="8100000" y="1134000"/>
             <a:ext cx="1800000" cy="1800000"/>
           </a:xfrm>
           <a:prstGeom prst="rect">
@@ -3869,7 +3786,7 @@
         </p:nvSpPr>
         <p:spPr>
           <a:xfrm>
-            <a:off x="7524000" y="2700000"/>
+            <a:off x="7812000" y="2988000"/>
             <a:ext cx="2376000" cy="216000"/>
           </a:xfrm>
           <a:prstGeom prst="rect">
@@ -3896,42 +3813,16 @@
           </a:p>
         </p:txBody>
       </p:sp>
-    </p:spTree>
-  </p:cSld>
-  <p:clrMapOvr>
-    <a:masterClrMapping/>
-  </p:clrMapOvr>
-</p:sld>
-</file>
-
-<file path=ppt/slides/slide2.xml><?xml version="1.0" encoding="utf-8"?>
-<p:sld xmlns:a="http://schemas.openxmlformats.org/drawingml/2006/main" xmlns:p="http://schemas.openxmlformats.org/presentationml/2006/main" xmlns:r="http://schemas.openxmlformats.org/officeDocument/2006/relationships">
-  <p:cSld>
-    <p:bg>
-      <p:bgPr>
-        <a:solidFill>
-          <a:srgbClr val="FBF7F0"/>
-        </a:solidFill>
-        <a:effectLst/>
-      </p:bgPr>
-    </p:bg>
-    <p:spTree>
-      <p:nvGrpSpPr>
-        <p:cNvPr id="1" name=""/>
-        <p:cNvGrpSpPr/>
-        <p:nvPr/>
-      </p:nvGrpSpPr>
-      <p:grpSpPr/>
-      <p:sp>
-        <p:nvSpPr>
-          <p:cNvPr id="2" name="Rectangle 1"/>
+      <p:sp>
+        <p:nvSpPr>
+          <p:cNvPr id="10" name="Rectangle 9"/>
           <p:cNvSpPr/>
           <p:nvPr/>
         </p:nvSpPr>
         <p:spPr>
           <a:xfrm>
-            <a:off x="18000" y="18000"/>
-            <a:ext cx="10080000" cy="3276000"/>
+            <a:off x="288000" y="3960000"/>
+            <a:ext cx="10116000" cy="3312000"/>
           </a:xfrm>
           <a:prstGeom prst="rect">
             <a:avLst/>
@@ -3968,13 +3859,13 @@
       </p:sp>
       <p:sp>
         <p:nvSpPr>
-          <p:cNvPr id="3" name="Rectangle 2"/>
+          <p:cNvPr id="11" name="Rectangle 10"/>
           <p:cNvSpPr/>
           <p:nvPr/>
         </p:nvSpPr>
         <p:spPr>
           <a:xfrm>
-            <a:off x="0" y="0"/>
+            <a:off x="288000" y="3960000"/>
             <a:ext cx="10116000" cy="432000"/>
           </a:xfrm>
           <a:prstGeom prst="rect">
@@ -4010,13 +3901,13 @@
       </p:sp>
       <p:sp>
         <p:nvSpPr>
-          <p:cNvPr id="4" name="TextBox 3"/>
+          <p:cNvPr id="12" name="TextBox 11"/>
           <p:cNvSpPr txBox="1"/>
           <p:nvPr/>
         </p:nvSpPr>
         <p:spPr>
           <a:xfrm>
-            <a:off x="504000" y="0"/>
+            <a:off x="792000" y="3960000"/>
             <a:ext cx="9108000" cy="432000"/>
           </a:xfrm>
           <a:prstGeom prst="rect">
@@ -4045,13 +3936,13 @@
       </p:sp>
       <p:sp>
         <p:nvSpPr>
-          <p:cNvPr id="5" name="TextBox 4"/>
+          <p:cNvPr id="13" name="TextBox 12"/>
           <p:cNvSpPr txBox="1"/>
           <p:nvPr/>
         </p:nvSpPr>
         <p:spPr>
           <a:xfrm>
-            <a:off x="504000" y="1188000"/>
+            <a:off x="792000" y="5148000"/>
             <a:ext cx="7092000" cy="720000"/>
           </a:xfrm>
           <a:prstGeom prst="rect">
@@ -4080,13 +3971,13 @@
       </p:sp>
       <p:sp>
         <p:nvSpPr>
-          <p:cNvPr id="6" name="TextBox 5"/>
+          <p:cNvPr id="14" name="TextBox 13"/>
           <p:cNvSpPr txBox="1"/>
           <p:nvPr/>
         </p:nvSpPr>
         <p:spPr>
           <a:xfrm>
-            <a:off x="504000" y="1962000"/>
+            <a:off x="792000" y="5922000"/>
             <a:ext cx="7092000" cy="288000"/>
           </a:xfrm>
           <a:prstGeom prst="rect">
@@ -4115,13 +4006,13 @@
       </p:sp>
       <p:sp>
         <p:nvSpPr>
-          <p:cNvPr id="7" name="TextBox 6"/>
+          <p:cNvPr id="15" name="TextBox 14"/>
           <p:cNvSpPr txBox="1"/>
           <p:nvPr/>
         </p:nvSpPr>
         <p:spPr>
           <a:xfrm>
-            <a:off x="504000" y="2304000"/>
+            <a:off x="792000" y="6264000"/>
             <a:ext cx="7092000" cy="252000"/>
           </a:xfrm>
           <a:prstGeom prst="rect">
@@ -4150,7 +4041,7 @@
       </p:sp>
       <p:pic>
         <p:nvPicPr>
-          <p:cNvPr id="8" name="Picture 7" descr="qr-review.png"/>
+          <p:cNvPr id="16" name="Picture 15" descr="qr-review.png"/>
           <p:cNvPicPr>
             <a:picLocks noChangeAspect="1"/>
           </p:cNvPicPr>
@@ -4164,7 +4055,7 @@
         </p:blipFill>
         <p:spPr>
           <a:xfrm>
-            <a:off x="7812000" y="846000"/>
+            <a:off x="8100000" y="4806000"/>
             <a:ext cx="1800000" cy="1800000"/>
           </a:xfrm>
           <a:prstGeom prst="rect">
@@ -4174,13 +4065,13 @@
       </p:pic>
       <p:sp>
         <p:nvSpPr>
-          <p:cNvPr id="9" name="TextBox 8"/>
+          <p:cNvPr id="17" name="TextBox 16"/>
           <p:cNvSpPr txBox="1"/>
           <p:nvPr/>
         </p:nvSpPr>
         <p:spPr>
           <a:xfrm>
-            <a:off x="7524000" y="2700000"/>
+            <a:off x="7812000" y="6660000"/>
             <a:ext cx="2376000" cy="216000"/>
           </a:xfrm>
           <a:prstGeom prst="rect">
@@ -4203,6 +4094,77 @@
                 <a:latin typeface="Trebuchet MS"/>
               </a:rPr>
               <a:t>REVIEW US</a:t>
+            </a:r>
+          </a:p>
+        </p:txBody>
+      </p:sp>
+      <p:cxnSp>
+        <p:nvCxnSpPr>
+          <p:cNvPr id="18" name="Connector 17"/>
+          <p:cNvCxnSpPr/>
+          <p:nvPr/>
+        </p:nvCxnSpPr>
+        <p:spPr>
+          <a:xfrm>
+            <a:off x="288000" y="3780000"/>
+            <a:ext cx="10116000" cy="0"/>
+          </a:xfrm>
+          <a:prstGeom prst="line">
+            <a:avLst/>
+          </a:prstGeom>
+          <a:ln w="9525">
+            <a:solidFill>
+              <a:srgbClr val="C4BCB0"/>
+            </a:solidFill>
+            <a:prstDash val="dash"/>
+          </a:ln>
+        </p:spPr>
+        <p:style>
+          <a:lnRef idx="2">
+            <a:schemeClr val="accent1"/>
+          </a:lnRef>
+          <a:fillRef idx="0">
+            <a:schemeClr val="accent1"/>
+          </a:fillRef>
+          <a:effectRef idx="1">
+            <a:schemeClr val="accent1"/>
+          </a:effectRef>
+          <a:fontRef idx="minor">
+            <a:schemeClr val="tx1"/>
+          </a:fontRef>
+        </p:style>
+      </p:cxnSp>
+      <p:sp>
+        <p:nvSpPr>
+          <p:cNvPr id="19" name="TextBox 18"/>
+          <p:cNvSpPr txBox="1"/>
+          <p:nvPr/>
+        </p:nvSpPr>
+        <p:spPr>
+          <a:xfrm>
+            <a:off x="8244000" y="3582000"/>
+            <a:ext cx="2160000" cy="180000"/>
+          </a:xfrm>
+          <a:prstGeom prst="rect">
+            <a:avLst/>
+          </a:prstGeom>
+          <a:noFill/>
+        </p:spPr>
+        <p:txBody>
+          <a:bodyPr wrap="square" anchor="t" lIns="0" rIns="0" tIns="0" bIns="0">
+            <a:spAutoFit/>
+          </a:bodyPr>
+          <a:lstStyle/>
+          <a:p>
+            <a:pPr algn="r"/>
+            <a:r>
+              <a:rPr sz="800" b="0">
+                <a:solidFill>
+                  <a:srgbClr val="A99F92"/>
+                </a:solidFill>
+                <a:latin typeface="Calibri"/>
+              </a:rPr>
+              <a:t>schneiden / cut</a:t>
             </a:r>
           </a:p>
         </p:txBody>

</xml_diff>

<commit_message>
Deck: A4 rather than Custom, no cut label, text block up 10%
Three changes in one rebuild.

The slide is now declared A4. It was already 297 x 210mm, but without the
sldSz type attribute PowerPoint reports "Custom", which is the wrong thing
for whoever prints it to be told. The enum is capitalised - "a4" is not a
member and the schema validator rejected it, which is how that was caught.

The "schneiden / cut" label is gone from both formats. The dashed line
stays.

The text block moves up 9mm, about a tenth of the strip, which lands the
address level with the top of the code: address at y=32.0, code at 31.5.
The HTML column is pinned rather than centred to match.

Checked by reading the deck back: one slide, 17 shapes, nothing off-page,
every run measured against its box with the real Windows font files, and
the package schema clean.

Co-Authored-By: Claude Opus 5 <noreply@anthropic.com>
</commit_message>
<xml_diff>
--- a/print/banner.pptx
+++ b/print/banner.pptx
@@ -7,7 +7,7 @@
   <p:sldIdLst>
     <p:sldId id="256" r:id="rId7"/>
   </p:sldIdLst>
-  <p:sldSz cx="10692000" cy="7560000" type="screen4x3"/>
+  <p:sldSz cx="10692000" cy="7560000" type="A4"/>
   <p:notesSz cx="6858000" cy="9144000"/>
   <p:defaultTextStyle>
     <a:defPPr>
@@ -3657,7 +3657,7 @@
         </p:nvSpPr>
         <p:spPr>
           <a:xfrm>
-            <a:off x="792000" y="1476000"/>
+            <a:off x="792000" y="1152000"/>
             <a:ext cx="7092000" cy="720000"/>
           </a:xfrm>
           <a:prstGeom prst="rect">
@@ -3692,7 +3692,7 @@
         </p:nvSpPr>
         <p:spPr>
           <a:xfrm>
-            <a:off x="792000" y="2250000"/>
+            <a:off x="792000" y="1926000"/>
             <a:ext cx="7092000" cy="288000"/>
           </a:xfrm>
           <a:prstGeom prst="rect">
@@ -3727,7 +3727,7 @@
         </p:nvSpPr>
         <p:spPr>
           <a:xfrm>
-            <a:off x="792000" y="2592000"/>
+            <a:off x="792000" y="2268000"/>
             <a:ext cx="7092000" cy="252000"/>
           </a:xfrm>
           <a:prstGeom prst="rect">
@@ -3942,7 +3942,7 @@
         </p:nvSpPr>
         <p:spPr>
           <a:xfrm>
-            <a:off x="792000" y="5148000"/>
+            <a:off x="792000" y="4824000"/>
             <a:ext cx="7092000" cy="720000"/>
           </a:xfrm>
           <a:prstGeom prst="rect">
@@ -3977,7 +3977,7 @@
         </p:nvSpPr>
         <p:spPr>
           <a:xfrm>
-            <a:off x="792000" y="5922000"/>
+            <a:off x="792000" y="5598000"/>
             <a:ext cx="7092000" cy="288000"/>
           </a:xfrm>
           <a:prstGeom prst="rect">
@@ -4012,7 +4012,7 @@
         </p:nvSpPr>
         <p:spPr>
           <a:xfrm>
-            <a:off x="792000" y="6264000"/>
+            <a:off x="792000" y="5940000"/>
             <a:ext cx="7092000" cy="252000"/>
           </a:xfrm>
           <a:prstGeom prst="rect">
@@ -4134,41 +4134,6 @@
           </a:fontRef>
         </p:style>
       </p:cxnSp>
-      <p:sp>
-        <p:nvSpPr>
-          <p:cNvPr id="19" name="TextBox 18"/>
-          <p:cNvSpPr txBox="1"/>
-          <p:nvPr/>
-        </p:nvSpPr>
-        <p:spPr>
-          <a:xfrm>
-            <a:off x="8244000" y="3582000"/>
-            <a:ext cx="2160000" cy="180000"/>
-          </a:xfrm>
-          <a:prstGeom prst="rect">
-            <a:avLst/>
-          </a:prstGeom>
-          <a:noFill/>
-        </p:spPr>
-        <p:txBody>
-          <a:bodyPr wrap="square" anchor="t" lIns="0" rIns="0" tIns="0" bIns="0">
-            <a:spAutoFit/>
-          </a:bodyPr>
-          <a:lstStyle/>
-          <a:p>
-            <a:pPr algn="r"/>
-            <a:r>
-              <a:rPr sz="800" b="0">
-                <a:solidFill>
-                  <a:srgbClr val="A99F92"/>
-                </a:solidFill>
-                <a:latin typeface="Calibri"/>
-              </a:rPr>
-              <a:t>schneiden / cut</a:t>
-            </a:r>
-          </a:p>
-        </p:txBody>
-      </p:sp>
     </p:spTree>
   </p:cSld>
   <p:clrMapOvr>

</xml_diff>